<commit_message>
Add A1–A10 assignment specs and M1–M5 capstone milestones; reconcile IDs; trim decks
- 10 assignment specifications (A1–A10, 6 pts, due Sundays 11:59 PM PST)
- 5 capstone milestone handouts (M1–M5) totaling 20 pts, plus an index
- Renumber assignments course-wide (S1→A7, A6→A9, S2→A10) and align
  Weeks 9/11/14 to capstone milestones; Week 10 → A8
- Trim long slide decks (W8 21→16, W11/W13 18→15)
- Update Syllabus grading to points model; weekly Lecture Video + capstone
  milestones in the Schedule; index links in READMEs
</commit_message>
<xml_diff>
--- a/CSCI250-Fall2026/content/Week09_Prompt-Engineering/slides.pptx
+++ b/CSCI250-Fall2026/content/Week09_Prompt-Engineering/slides.pptx
@@ -5584,7 +5584,7 @@
                 </a:solidFill>
                 <a:latin typeface="Calibri"/>
               </a:rPr>
-              <a:t>✓ Capstone: 'My Assistant' v1 — give it a role + reasoning style</a:t>
+              <a:t>✓ Practice (ungraded): build &amp; refine a JSON-output tool; test on 3 inputs</a:t>
             </a:r>
           </a:p>
           <a:p>
@@ -5600,7 +5600,7 @@
                 </a:solidFill>
                 <a:latin typeface="Calibri"/>
               </a:rPr>
-              <a:t>✓ Build &amp; refine a JSON-output tool; test on 3 inputs</a:t>
+              <a:t>✓ Capstone M1: write your proposal + 'My Assistant' v1 (role + reasoning style)</a:t>
             </a:r>
           </a:p>
           <a:p>
@@ -5616,7 +5616,7 @@
                 </a:solidFill>
                 <a:latin typeface="Calibri"/>
               </a:rPr>
-              <a:t>✓ Submit Assignment A4 by Sunday 11:59 PM PT</a:t>
+              <a:t>✓ Submit Capstone M1 by Sunday 11:59 PM PST</a:t>
             </a:r>
           </a:p>
         </p:txBody>

</xml_diff>